<commit_message>
Update PPT: Bridge industry metrics with Saheli's mechanics
</commit_message>
<xml_diff>
--- a/deck/Saheli.pptx
+++ b/deck/Saheli.pptx
@@ -2286,7 +2286,7 @@
                 <a:ea typeface="Calibri" pitchFamily="34" charset="-122"/>
                 <a:cs typeface="Calibri" pitchFamily="34" charset="-120"/>
               </a:rPr>
-              <a:t>to decision paralysis and unresolved doubt, not price</a:t>
+              <a:t>due to review fatigue and lack of trust, not just price</a:t>
             </a:r>
             <a:endParaRPr lang="en-US" sz="1400" dirty="0"/>
           </a:p>
@@ -2378,7 +2378,7 @@
                 <a:ea typeface="Georgia" pitchFamily="34" charset="-122"/>
                 <a:cs typeface="Georgia" pitchFamily="34" charset="-120"/>
               </a:rPr>
-              <a:t>Returns that hurt</a:t>
+              <a:t>20-30% Return rates</a:t>
             </a:r>
             <a:endParaRPr lang="en-US" sz="1900" dirty="0"/>
           </a:p>
@@ -2417,7 +2417,7 @@
                 <a:ea typeface="Calibri" pitchFamily="34" charset="-122"/>
                 <a:cs typeface="Calibri" pitchFamily="34" charset="-120"/>
               </a:rPr>
-              <a:t>Apparel return rates hit 20-30%, destroying platform margins</a:t>
+              <a:t>driven by missed sizing warnings buried deep in reviews</a:t>
             </a:r>
             <a:endParaRPr lang="en-US" sz="1400" dirty="0"/>
           </a:p>
@@ -4795,7 +4795,7 @@
                 <a:ea typeface="Calibri" pitchFamily="34" charset="-122"/>
                 <a:cs typeface="Calibri" pitchFamily="34" charset="-120"/>
               </a:rPr>
-              <a:t>hours, or abandoned, → under 2 min — you just watched it happen</a:t>
+              <a:t>hours of WhatsApping → under 2 min. Saheli acts as the closer.</a:t>
             </a:r>
             <a:endParaRPr lang="en-US" sz="1350" dirty="0"/>
           </a:p>
@@ -4926,7 +4926,7 @@
                 <a:ea typeface="Calibri" pitchFamily="34" charset="-122"/>
                 <a:cs typeface="Calibri" pitchFamily="34" charset="-120"/>
               </a:rPr>
-              <a:t>Drops the 75% cart abandonment rate by resolving hesitation live</a:t>
+              <a:t>Drops the 75% abandonment rate by resolving trust issues live.</a:t>
             </a:r>
             <a:endParaRPr lang="en-US" sz="1350" dirty="0"/>
           </a:p>
@@ -5057,7 +5057,7 @@
                 <a:ea typeface="Calibri" pitchFamily="34" charset="-122"/>
                 <a:cs typeface="Calibri" pitchFamily="34" charset="-120"/>
               </a:rPr>
-              <a:t>Intercepts the #1 cause of returns (wrong size / specs) before checkout</a:t>
+              <a:t>Saheli reads 'runs small' in the reviews before they checkout.</a:t>
             </a:r>
             <a:endParaRPr lang="en-US" sz="1350" dirty="0"/>
           </a:p>

</xml_diff>